<commit_message>
Centraliza o texto do slide de encerramento
"Obrigado.", o subtítulo de autoria e "Perguntas?" estavam alinhados à
esquerda por padrão, destoando dos cards de contato e do aviso legal
(já centralizados) — verificado renderizando o slide via COM do
PowerPoint antes e depois da correção.

Co-Authored-By: Claude Sonnet 5 <noreply@anthropic.com>
Claude-Session: https://claude.ai/code/session_017q6pUdQxrP1ALdtJ7GSq6w
</commit_message>
<xml_diff>
--- a/site/sistematicos-apresentacao.pptx
+++ b/site/sistematicos-apresentacao.pptx
@@ -18245,6 +18245,7 @@
           </a:bodyPr>
           <a:lstStyle/>
           <a:p>
+            <a:pPr algn="ctr"/>
             <a:r>
               <a:rPr sz="1200" b="1" i="0" spc="220">
                 <a:solidFill>
@@ -18279,6 +18280,7 @@
           </a:bodyPr>
           <a:lstStyle/>
           <a:p>
+            <a:pPr algn="ctr"/>
             <a:r>
               <a:rPr sz="5200" b="1" i="1">
                 <a:solidFill>
@@ -18313,7 +18315,7 @@
           </a:bodyPr>
           <a:lstStyle/>
           <a:p>
-            <a:pPr>
+            <a:pPr algn="ctr">
               <a:lnSpc>
                 <a:spcPct val="120000"/>
               </a:lnSpc>
@@ -18723,6 +18725,7 @@
           </a:bodyPr>
           <a:lstStyle/>
           <a:p>
+            <a:pPr algn="ctr"/>
             <a:r>
               <a:rPr sz="2600" b="1" i="1">
                 <a:solidFill>

</xml_diff>